<commit_message>
Reencuadrar el pitch: dos alumnos exponiendo, no una consultora
La consigna pide asumir el rol de una consultora analítica. Ahora eso se
menciona una vez, como parte del enunciado del caso, y de ahí en más se habla
en primera persona: dos alumnos mostrando el trabajo que hicieron.

- Portada: pasa a "Trabajo práctico · Unidad 3", con la materia, el caso y un
  campo de integrantes a completar con el nombre del compañero.
- Apertura del guion: presentación por nombre, el caso como enunciado y la
  perspectiva elegida explicitada.
- Cierre: se saca el "quedamos a disposición", que era lenguaje de proveedor.
- Se regeneraron el PDF de láminas y el del guion.

Co-Authored-By: Claude Opus 5 <noreply@anthropic.com>
</commit_message>
<xml_diff>
--- a/docs/MiniRed_Pitch.pptx
+++ b/docs/MiniRed_Pitch.pptx
@@ -1237,7 +1237,7 @@
           <a:p>
             <a:r>
               <a:rPr lang="en-US" dirty="0"/>
-              <a:t>Somos la consultora. En 10 minutos: qué encontramos, cómo lo validamos, y qué haría MiniRed con esto. Arranco por el problema, no por la tecnología.</a:t>
+              <a:t>Presentarse por nombre. En 10 minutos: qué encontramos, cómo lo validamos y qué recomienda el análisis. Arrancar por el problema, no por la tecnología.</a:t>
             </a:r>
             <a:endParaRPr lang="en-US" dirty="0"/>
           </a:p>
@@ -2783,7 +2783,7 @@
         <p:spPr>
           <a:xfrm>
             <a:off x="640080" y="1371600"/>
-            <a:ext cx="1920240" cy="256032"/>
+            <a:ext cx="2483510" cy="256032"/>
           </a:xfrm>
           <a:prstGeom prst="roundRect">
             <a:avLst>
@@ -2810,7 +2810,7 @@
         <p:spPr>
           <a:xfrm>
             <a:off x="640080" y="1371600"/>
-            <a:ext cx="1920240" cy="256032"/>
+            <a:ext cx="2483510" cy="256032"/>
           </a:xfrm>
           <a:prstGeom prst="rect">
             <a:avLst/>
@@ -2834,7 +2834,7 @@
                 <a:ea typeface="Calibri" pitchFamily="34" charset="-122"/>
                 <a:cs typeface="Calibri" pitchFamily="34" charset="-120"/>
               </a:rPr>
-              <a:t>CONSULTORA ANALÍTICA</a:t>
+              <a:t>TRABAJO PRÁCTICO · UNIDAD 3</a:t>
             </a:r>
             <a:endParaRPr lang="en-US" sz="1000" dirty="0"/>
           </a:p>
@@ -2849,23 +2849,26 @@
         <p:spPr>
           <a:xfrm>
             <a:off x="640080" y="1783080"/>
-            <a:ext cx="3017520" cy="548640"/>
-          </a:xfrm>
-          <a:prstGeom prst="rect">
-            <a:avLst/>
-          </a:prstGeom>
-          <a:noFill/>
-          <a:ln/>
-        </p:spPr>
-        <p:txBody>
-          <a:bodyPr wrap="square" lIns="0" tIns="0" rIns="0" bIns="0" rtlCol="0" anchor="ctr"/>
-          <a:lstStyle/>
-          <a:p>
-            <a:pPr indent="0" marL="0">
-              <a:buNone/>
-            </a:pPr>
-            <a:r>
-              <a:rPr lang="en-US" sz="3000" b="1" dirty="0">
+            <a:ext cx="3108960" cy="1280160"/>
+          </a:xfrm>
+          <a:prstGeom prst="rect">
+            <a:avLst/>
+          </a:prstGeom>
+          <a:noFill/>
+          <a:ln/>
+        </p:spPr>
+        <p:txBody>
+          <a:bodyPr wrap="square" lIns="0" tIns="0" rIns="0" bIns="0" rtlCol="0" anchor="ctr"/>
+          <a:lstStyle/>
+          <a:p>
+            <a:pPr indent="0" marL="0">
+              <a:lnSpc>
+                <a:spcPts val="2700"/>
+              </a:lnSpc>
+              <a:buNone/>
+            </a:pPr>
+            <a:r>
+              <a:rPr lang="en-US" sz="2100" b="1" dirty="0">
                 <a:solidFill>
                   <a:srgbClr val="FFFFFF"/>
                 </a:solidFill>
@@ -2873,9 +2876,49 @@
                 <a:ea typeface="Cambria" pitchFamily="34" charset="-122"/>
                 <a:cs typeface="Cambria" pitchFamily="34" charset="-120"/>
               </a:rPr>
-              <a:t>MiniRed S.A.</a:t>
-            </a:r>
-            <a:endParaRPr lang="en-US" sz="3000" dirty="0"/>
+              <a:t>Minería de Datos,</a:t>
+            </a:r>
+            <a:endParaRPr lang="en-US" sz="2100" dirty="0"/>
+          </a:p>
+          <a:p>
+            <a:pPr indent="0" marL="0">
+              <a:lnSpc>
+                <a:spcPts val="2700"/>
+              </a:lnSpc>
+              <a:buNone/>
+            </a:pPr>
+            <a:r>
+              <a:rPr lang="en-US" sz="2100" b="1" dirty="0">
+                <a:solidFill>
+                  <a:srgbClr val="FFFFFF"/>
+                </a:solidFill>
+                <a:latin typeface="Cambria" pitchFamily="34" charset="0"/>
+                <a:ea typeface="Cambria" pitchFamily="34" charset="-122"/>
+                <a:cs typeface="Cambria" pitchFamily="34" charset="-120"/>
+              </a:rPr>
+              <a:t>KDD y Modelado</a:t>
+            </a:r>
+            <a:endParaRPr lang="en-US" sz="2100" dirty="0"/>
+          </a:p>
+          <a:p>
+            <a:pPr indent="0" marL="0">
+              <a:lnSpc>
+                <a:spcPts val="2700"/>
+              </a:lnSpc>
+              <a:buNone/>
+            </a:pPr>
+            <a:r>
+              <a:rPr lang="en-US" sz="2100" b="1" dirty="0">
+                <a:solidFill>
+                  <a:srgbClr val="FFFFFF"/>
+                </a:solidFill>
+                <a:latin typeface="Cambria" pitchFamily="34" charset="0"/>
+                <a:ea typeface="Cambria" pitchFamily="34" charset="-122"/>
+                <a:cs typeface="Cambria" pitchFamily="34" charset="-120"/>
+              </a:rPr>
+              <a:t>Dimensional</a:t>
+            </a:r>
+            <a:endParaRPr lang="en-US" sz="2100" dirty="0"/>
           </a:p>
         </p:txBody>
       </p:sp>
@@ -2887,8 +2930,8 @@
         </p:nvSpPr>
         <p:spPr>
           <a:xfrm>
-            <a:off x="640080" y="2395728"/>
-            <a:ext cx="3017520" cy="1005840"/>
+            <a:off x="640080" y="3246120"/>
+            <a:ext cx="3108960" cy="1463040"/>
           </a:xfrm>
           <a:prstGeom prst="rect">
             <a:avLst/>
@@ -2902,12 +2945,32 @@
           <a:p>
             <a:pPr indent="0" marL="0">
               <a:lnSpc>
-                <a:spcPts val="2000"/>
+                <a:spcPts val="1900"/>
               </a:lnSpc>
               <a:buNone/>
             </a:pPr>
             <a:r>
-              <a:rPr lang="en-US" sz="1300" dirty="0">
+              <a:rPr lang="en-US" sz="1250" b="1" dirty="0">
+                <a:solidFill>
+                  <a:srgbClr val="FFFFFF"/>
+                </a:solidFill>
+                <a:latin typeface="Calibri" pitchFamily="34" charset="0"/>
+                <a:ea typeface="Calibri" pitchFamily="34" charset="-122"/>
+                <a:cs typeface="Calibri" pitchFamily="34" charset="-120"/>
+              </a:rPr>
+              <a:t>Integrantes</a:t>
+            </a:r>
+            <a:endParaRPr lang="en-US" sz="1250" dirty="0"/>
+          </a:p>
+          <a:p>
+            <a:pPr indent="0" marL="0">
+              <a:lnSpc>
+                <a:spcPts val="1900"/>
+              </a:lnSpc>
+              <a:buNone/>
+            </a:pPr>
+            <a:r>
+              <a:rPr lang="en-US" sz="1250" dirty="0">
                 <a:solidFill>
                   <a:srgbClr val="9AA1AC"/>
                 </a:solidFill>
@@ -2915,19 +2978,19 @@
                 <a:ea typeface="Calibri" pitchFamily="34" charset="-122"/>
                 <a:cs typeface="Calibri" pitchFamily="34" charset="-120"/>
               </a:rPr>
-              <a:t>Cadena de minimercados</a:t>
-            </a:r>
-            <a:endParaRPr lang="en-US" sz="1300" dirty="0"/>
+              <a:t>Santiago Skrobacki</a:t>
+            </a:r>
+            <a:endParaRPr lang="en-US" sz="1250" dirty="0"/>
           </a:p>
           <a:p>
             <a:pPr indent="0" marL="0">
               <a:lnSpc>
-                <a:spcPts val="2000"/>
+                <a:spcPts val="1900"/>
               </a:lnSpc>
               <a:buNone/>
             </a:pPr>
             <a:r>
-              <a:rPr lang="en-US" sz="1300" dirty="0">
+              <a:rPr lang="en-US" sz="1250" dirty="0">
                 <a:solidFill>
                   <a:srgbClr val="9AA1AC"/>
                 </a:solidFill>
@@ -2935,19 +2998,19 @@
                 <a:ea typeface="Calibri" pitchFamily="34" charset="-122"/>
                 <a:cs typeface="Calibri" pitchFamily="34" charset="-120"/>
               </a:rPr>
-              <a:t>6 sucursales + depósito Central</a:t>
-            </a:r>
-            <a:endParaRPr lang="en-US" sz="1300" dirty="0"/>
+              <a:t>Nombre del compañero</a:t>
+            </a:r>
+            <a:endParaRPr lang="en-US" sz="1250" dirty="0"/>
           </a:p>
           <a:p>
             <a:pPr indent="0" marL="0">
               <a:lnSpc>
-                <a:spcPts val="2000"/>
+                <a:spcPts val="1900"/>
               </a:lnSpc>
               <a:buNone/>
             </a:pPr>
             <a:r>
-              <a:rPr lang="en-US" sz="1300" dirty="0">
+              <a:rPr lang="en-US" sz="1250" dirty="0">
                 <a:solidFill>
                   <a:srgbClr val="9AA1AC"/>
                 </a:solidFill>
@@ -2955,9 +3018,29 @@
                 <a:ea typeface="Calibri" pitchFamily="34" charset="-122"/>
                 <a:cs typeface="Calibri" pitchFamily="34" charset="-120"/>
               </a:rPr>
-              <a:t>2024 – 2025</a:t>
-            </a:r>
-            <a:endParaRPr lang="en-US" sz="1300" dirty="0"/>
+              <a:t>Caso: MiniRed S.A.</a:t>
+            </a:r>
+            <a:endParaRPr lang="en-US" sz="1250" dirty="0"/>
+          </a:p>
+          <a:p>
+            <a:pPr indent="0" marL="0">
+              <a:lnSpc>
+                <a:spcPts val="1900"/>
+              </a:lnSpc>
+              <a:buNone/>
+            </a:pPr>
+            <a:r>
+              <a:rPr lang="en-US" sz="1250" dirty="0">
+                <a:solidFill>
+                  <a:srgbClr val="9AA1AC"/>
+                </a:solidFill>
+                <a:latin typeface="Calibri" pitchFamily="34" charset="0"/>
+                <a:ea typeface="Calibri" pitchFamily="34" charset="-122"/>
+                <a:cs typeface="Calibri" pitchFamily="34" charset="-120"/>
+              </a:rPr>
+              <a:t>6 sucursales · 2024 – 2025</a:t>
+            </a:r>
+            <a:endParaRPr lang="en-US" sz="1250" dirty="0"/>
           </a:p>
         </p:txBody>
       </p:sp>
@@ -3032,7 +3115,7 @@
         <p:spPr>
           <a:xfrm>
             <a:off x="5029200" y="4114800"/>
-            <a:ext cx="6217920" cy="731520"/>
+            <a:ext cx="6309360" cy="914400"/>
           </a:xfrm>
           <a:prstGeom prst="rect">
             <a:avLst/>
@@ -3046,12 +3129,12 @@
           <a:p>
             <a:pPr indent="0" marL="0">
               <a:lnSpc>
-                <a:spcPts val="2200"/>
+                <a:spcPts val="2100"/>
               </a:lnSpc>
               <a:buNone/>
             </a:pPr>
             <a:r>
-              <a:rPr lang="en-US" sz="1500" dirty="0">
+              <a:rPr lang="en-US" sz="1400" dirty="0">
                 <a:solidFill>
                   <a:srgbClr val="E9A13B"/>
                 </a:solidFill>
@@ -3059,9 +3142,9 @@
                 <a:ea typeface="Calibri" pitchFamily="34" charset="-122"/>
                 <a:cs typeface="Calibri" pitchFamily="34" charset="-120"/>
               </a:rPr>
-              <a:t>Análisis de quiebres de stock y rotación sobre el data warehouse MiniRed_DW</a:t>
-            </a:r>
-            <a:endParaRPr lang="en-US" sz="1500" dirty="0"/>
+              <a:t>El trabajo plantea el caso de una cadena de minimercados y pide resolver un desafío de abastecimiento sobre su data warehouse.</a:t>
+            </a:r>
+            <a:endParaRPr lang="en-US" sz="1400" dirty="0"/>
           </a:p>
         </p:txBody>
       </p:sp>
@@ -3098,7 +3181,7 @@
                 <a:ea typeface="Calibri" pitchFamily="34" charset="-122"/>
                 <a:cs typeface="Calibri" pitchFamily="34" charset="-120"/>
               </a:rPr>
-              <a:t>Perspectiva B · Logística e Inventario   |   Minería de Datos, KDD y Modelado Dimensional — Unidad 3</a:t>
+              <a:t>Perspectiva elegida: Opción B · Logística e Inventario</a:t>
             </a:r>
             <a:endParaRPr lang="en-US" sz="1100" dirty="0"/>
           </a:p>
@@ -6520,7 +6603,7 @@
                 <a:ea typeface="Calibri" pitchFamily="34" charset="-122"/>
                 <a:cs typeface="Calibri" pitchFamily="34" charset="-120"/>
               </a:rPr>
-              <a:t>Portal, código y documentación:  github.com/SantiagoSkrobacki/TP_MiniRedBaseDeDatos</a:t>
+              <a:t>Portal, código y documentación:  github.com/SantiagoSkrobacki/TP_MiniRedBaseDeDatos   ·   Gracias.</a:t>
             </a:r>
             <a:endParaRPr lang="en-US" sz="1200" dirty="0"/>
           </a:p>

</xml_diff>

<commit_message>
Separar explícitamente qué dice cada participante
A y B pasan a llamarse Participante 1 y Participante 2, y el reparto se
declara en tres lugares para que no haya dudas durante la exposición:

- Portada del guion: tabla con las diapositivas, los tramos y el tiempo de
  cada uno. Son cinco minutos exactos por cabeza.
- Cabecera de cada página: quién la presenta, con color propio.
- Dos hojas de ruta al final, una por participante, con sólo sus diapositivas
  y la primera frase de cada una para arrancar sin dudar. Para llevar en la
  mano durante la presentación.

Además las notas del orador del .pptx quedan prefijadas con [PARTICIPANTE N],
así el reparto también se ve en la Vista Moderador.

Co-Authored-By: Claude Opus 5 <noreply@anthropic.com>
</commit_message>
<xml_diff>
--- a/docs/MiniRed_Pitch.pptx
+++ b/docs/MiniRed_Pitch.pptx
@@ -1237,7 +1237,7 @@
           <a:p>
             <a:r>
               <a:rPr lang="en-US" dirty="0"/>
-              <a:t>Presentarse por nombre. En 10 minutos: qué encontramos, cómo lo validamos y qué recomienda el análisis. Arrancar por el problema, no por la tecnología.</a:t>
+              <a:t>[PARTICIPANTE 1]  Presentarse por nombre. En 10 minutos: qué encontramos, cómo lo validamos y qué recomienda el análisis. Arrancar por el problema, no por la tecnología.</a:t>
             </a:r>
             <a:endParaRPr lang="en-US" dirty="0"/>
           </a:p>
@@ -1325,7 +1325,7 @@
           <a:p>
             <a:r>
               <a:rPr lang="en-US" dirty="0"/>
-              <a:t>Punto 5, primera mitad: sobreajuste. La segunda mitad es la lámina que sigue.</a:t>
+              <a:t>[PARTICIPANTE 2]  Punto 5, primera mitad: sobreajuste. La segunda mitad es la lámina que sigue.</a:t>
             </a:r>
             <a:endParaRPr lang="en-US" dirty="0"/>
           </a:p>
@@ -1413,7 +1413,7 @@
           <a:p>
             <a:r>
               <a:rPr lang="en-US" dirty="0"/>
-              <a:t>La lámina más fuerte del pitch. Pausar acá. Si hay una sola pregunta del jurado, va a salir de esta diapositiva.</a:t>
+              <a:t>[PARTICIPANTE 2]  La lámina más fuerte del pitch. Pausar acá. Si hay una sola pregunta del jurado, va a salir de esta diapositiva.</a:t>
             </a:r>
             <a:endParaRPr lang="en-US" dirty="0"/>
           </a:p>
@@ -1501,7 +1501,7 @@
           <a:p>
             <a:r>
               <a:rPr lang="en-US" dirty="0"/>
-              <a:t>Cerrar con acciones, no con números. El jurado quiere ver que el análisis termina en una decisión.</a:t>
+              <a:t>[PARTICIPANTE 1]  Cerrar con acciones, no con números. El jurado quiere ver que el análisis termina en una decisión.</a:t>
             </a:r>
             <a:endParaRPr lang="en-US" dirty="0"/>
           </a:p>
@@ -1589,7 +1589,7 @@
           <a:p>
             <a:r>
               <a:rPr lang="en-US" dirty="0"/>
-              <a:t>Abrir el portal en otra ventana ANTES de empezar el pitch. Si falla internet, la copia embebida hace que abra igual con doble clic.</a:t>
+              <a:t>[PARTICIPANTE 2]  Abrir el portal en otra ventana ANTES de empezar el pitch. Si falla internet, la copia embebida hace que abra igual con doble clic.</a:t>
             </a:r>
             <a:endParaRPr lang="en-US" dirty="0"/>
           </a:p>
@@ -1677,7 +1677,7 @@
           <a:p>
             <a:r>
               <a:rPr lang="en-US" dirty="0"/>
-              <a:t>Cierre en una sola idea: un supuesto mal puesto en la política de reposición explica los cuatro hallazgos. Abrir preguntas.</a:t>
+              <a:t>[PARTICIPANTE 1]  Cierre en una sola idea: un supuesto mal puesto en la política de reposición explica los cuatro hallazgos. Abrir preguntas.</a:t>
             </a:r>
             <a:endParaRPr lang="en-US" dirty="0"/>
           </a:p>
@@ -1765,7 +1765,7 @@
           <a:p>
             <a:r>
               <a:rPr lang="en-US" dirty="0"/>
-              <a:t>Insistir: no alcanza con 'reponer más'. Una sucursal con cero quiebre puede ser la peor gestionada de la cadena. Ese es el hallazgo que más sorprende y lo mostramos en el minuto 6.</a:t>
+              <a:t>[PARTICIPANTE 1]  Insistir: no alcanza con 'reponer más'. Una sucursal con cero quiebre puede ser la peor gestionada de la cadena. Ese es el hallazgo que más sorprende y lo mostramos en el minuto 6.</a:t>
             </a:r>
             <a:endParaRPr lang="en-US" dirty="0"/>
           </a:p>
@@ -1853,7 +1853,7 @@
           <a:p>
             <a:r>
               <a:rPr lang="en-US" dirty="0"/>
-              <a:t>Declararlo de entrada quita el aire a la pregunta incómoda. Y convierte una limitación en material teórico.</a:t>
+              <a:t>[PARTICIPANTE 1]  Declararlo de entrada quita el aire a la pregunta incómoda. Y convierte una limitación en material teórico.</a:t>
             </a:r>
             <a:endParaRPr lang="en-US" dirty="0"/>
           </a:p>
@@ -1941,7 +1941,7 @@
           <a:p>
             <a:r>
               <a:rPr lang="en-US" dirty="0"/>
-              <a:t>Si preguntan por qué no una sola tabla: distinto grano. Un ticket es un evento; el stock es una foto diaria. Meterlos juntos rompe la aditividad.</a:t>
+              <a:t>[PARTICIPANTE 2]  Si preguntan por qué no una sola tabla: distinto grano. Un ticket es un evento; el stock es una foto diaria. Meterlos juntos rompe la aditividad.</a:t>
             </a:r>
             <a:endParaRPr lang="en-US" dirty="0"/>
           </a:p>
@@ -2029,7 +2029,7 @@
           <a:p>
             <a:r>
               <a:rPr lang="en-US" dirty="0"/>
-              <a:t>Este es el punto técnico que más pesa. Si sólo se llevan una cosa del pitch, que sea ésta: el 750x de diferencia entre sumar mal y sumar bien.</a:t>
+              <a:t>[PARTICIPANTE 2]  Este es el punto técnico que más pesa. Si sólo se llevan una cosa del pitch, que sea ésta: el 750x de diferencia entre sumar mal y sumar bien.</a:t>
             </a:r>
             <a:endParaRPr lang="en-US" dirty="0"/>
           </a:p>
@@ -2117,7 +2117,7 @@
           <a:p>
             <a:r>
               <a:rPr lang="en-US" dirty="0"/>
-              <a:t>Puntos 1 y 4 de la consigna resueltos en una sola lámina. El ejemplo del martes es concreto y se puede mostrar en vivo después.</a:t>
+              <a:t>[PARTICIPANTE 1]  Puntos 1 y 4 de la consigna resueltos en una sola lámina. El ejemplo del martes es concreto y se puede mostrar en vivo después.</a:t>
             </a:r>
             <a:endParaRPr lang="en-US" dirty="0"/>
           </a:p>
@@ -2205,7 +2205,7 @@
           <a:p>
             <a:r>
               <a:rPr lang="en-US" dirty="0"/>
-              <a:t>Punto 2. Mencionar que EsQuiebre se guarda como entero y no como bit, justamente porque se suma para contar días de faltante.</a:t>
+              <a:t>[PARTICIPANTE 1]  Punto 2. Mencionar que EsQuiebre se guarda como entero y no como bit, justamente porque se suma para contar días de faltante.</a:t>
             </a:r>
             <a:endParaRPr lang="en-US" dirty="0"/>
           </a:p>
@@ -2293,7 +2293,7 @@
           <a:p>
             <a:r>
               <a:rPr lang="en-US" dirty="0"/>
-              <a:t>Pasar rápido por 1 a 3 y detenerse en 4 y 5, que es donde está el contenido propio.</a:t>
+              <a:t>[PARTICIPANTE 1]  Pasar rápido por 1 a 3 y detenerse en 4 y 5, que es donde está el contenido propio.</a:t>
             </a:r>
             <a:endParaRPr lang="en-US" dirty="0"/>
           </a:p>
@@ -2381,7 +2381,7 @@
           <a:p>
             <a:r>
               <a:rPr lang="en-US" dirty="0"/>
-              <a:t>Punto 6. No leer las cuatro: contar R1 y R3, que son las más visuales, y dejar R2 para la lámina siguiente.</a:t>
+              <a:t>[PARTICIPANTE 2]  Punto 6. No leer las cuatro: contar R1 y R3, que son las más visuales, y dejar R2 para la lámina siguiente.</a:t>
             </a:r>
             <a:endParaRPr lang="en-US" dirty="0"/>
           </a:p>

</xml_diff>

<commit_message>
Un solo traspaso: el 1 expone las láminas 1 a 7, el 2 las 8 a 14
Antes el reparto era intercalado: cada uno entraba tres o cuatro veces. Ahora
habla uno de corrido y después el otro, con un único traspaso al terminar la
diapositiva 7.

El corte no reordena las láminas —hacerlo dejaría el cierre en el medio y el
impacto antes de las reglas que lo justifican—, sino que parte la secuencia en
dos mitades coherentes: el Participante 1 arma el terreno (problema, datos,
modelo dimensional, semi-aditividad) y el Participante 2 cuenta lo que se
encontró adentro y cierra (proceso, reglas, validación, impacto, demo).

Quedan 4:50 y 5:10 respectivamente.

El traspaso se destaca en su página y las notas del .pptx quedan reasignadas,
así también se ve en la Vista Moderador.

Co-Authored-By: Claude Opus 5 <noreply@anthropic.com>
</commit_message>
<xml_diff>
--- a/docs/MiniRed_Pitch.pptx
+++ b/docs/MiniRed_Pitch.pptx
@@ -1501,7 +1501,7 @@
           <a:p>
             <a:r>
               <a:rPr lang="en-US" dirty="0"/>
-              <a:t>[PARTICIPANTE 1]  Cerrar con acciones, no con números. El jurado quiere ver que el análisis termina en una decisión.</a:t>
+              <a:t>[PARTICIPANTE 2]  Cerrar con acciones, no con números. El jurado quiere ver que el análisis termina en una decisión.</a:t>
             </a:r>
             <a:endParaRPr lang="en-US" dirty="0"/>
           </a:p>
@@ -1677,7 +1677,7 @@
           <a:p>
             <a:r>
               <a:rPr lang="en-US" dirty="0"/>
-              <a:t>[PARTICIPANTE 1]  Cierre en una sola idea: un supuesto mal puesto en la política de reposición explica los cuatro hallazgos. Abrir preguntas.</a:t>
+              <a:t>[PARTICIPANTE 2]  Cierre en una sola idea: un supuesto mal puesto en la política de reposición explica los cuatro hallazgos. Abrir preguntas.</a:t>
             </a:r>
             <a:endParaRPr lang="en-US" dirty="0"/>
           </a:p>
@@ -1941,7 +1941,7 @@
           <a:p>
             <a:r>
               <a:rPr lang="en-US" dirty="0"/>
-              <a:t>[PARTICIPANTE 2]  Si preguntan por qué no una sola tabla: distinto grano. Un ticket es un evento; el stock es una foto diaria. Meterlos juntos rompe la aditividad.</a:t>
+              <a:t>[PARTICIPANTE 1]  Si preguntan por qué no una sola tabla: distinto grano. Un ticket es un evento; el stock es una foto diaria. Meterlos juntos rompe la aditividad.</a:t>
             </a:r>
             <a:endParaRPr lang="en-US" dirty="0"/>
           </a:p>
@@ -2029,7 +2029,7 @@
           <a:p>
             <a:r>
               <a:rPr lang="en-US" dirty="0"/>
-              <a:t>[PARTICIPANTE 2]  Este es el punto técnico que más pesa. Si sólo se llevan una cosa del pitch, que sea ésta: el 750x de diferencia entre sumar mal y sumar bien.</a:t>
+              <a:t>[PARTICIPANTE 1]  Este es el punto técnico que más pesa. Si sólo se llevan una cosa del pitch, que sea ésta: el 750x de diferencia entre sumar mal y sumar bien.</a:t>
             </a:r>
             <a:endParaRPr lang="en-US" dirty="0"/>
           </a:p>
@@ -2293,7 +2293,7 @@
           <a:p>
             <a:r>
               <a:rPr lang="en-US" dirty="0"/>
-              <a:t>[PARTICIPANTE 1]  Pasar rápido por 1 a 3 y detenerse en 4 y 5, que es donde está el contenido propio.</a:t>
+              <a:t>[PARTICIPANTE 2]  Pasar rápido por 1 a 3 y detenerse en 4 y 5, que es donde está el contenido propio.</a:t>
             </a:r>
             <a:endParaRPr lang="en-US" dirty="0"/>
           </a:p>

</xml_diff>